<commit_message>
fix: update old event storiming diagram
</commit_message>
<xml_diff>
--- a/Presentation/PV260 - SW Quality.pptx
+++ b/Presentation/PV260 - SW Quality.pptx
@@ -5958,49 +5958,49 @@
         <p:nvSpPr>
           <p:cNvPr id="55" name="Google Shape;55;p13"/>
           <p:cNvSpPr txBox="1"/>
-          <p:nvPr>
-            <p:ph idx="1" type="subTitle"/>
-          </p:nvPr>
+          <p:nvPr/>
         </p:nvSpPr>
         <p:spPr>
           <a:xfrm>
-            <a:off x="311700" y="2841300"/>
-            <a:ext cx="8520600" cy="792600"/>
+            <a:off x="1644450" y="2797175"/>
+            <a:ext cx="5855100" cy="538800"/>
           </a:xfrm>
           <a:prstGeom prst="rect">
             <a:avLst/>
           </a:prstGeom>
+          <a:noFill/>
+          <a:ln>
+            <a:noFill/>
+          </a:ln>
         </p:spPr>
         <p:txBody>
           <a:bodyPr anchorCtr="0" anchor="t" bIns="91425" lIns="91425" spcFirstLastPara="1" rIns="91425" wrap="square" tIns="91425">
-            <a:normAutofit fontScale="85000"/>
+            <a:spAutoFit/>
           </a:bodyPr>
           <a:lstStyle/>
           <a:p>
             <a:pPr indent="0" lvl="0" marL="0" rtl="0" algn="ctr">
-              <a:lnSpc>
-                <a:spcPct val="125000"/>
-              </a:lnSpc>
-              <a:spcBef>
-                <a:spcPts val="0"/>
-              </a:spcBef>
-              <a:spcAft>
-                <a:spcPts val="1200"/>
+              <a:spcBef>
+                <a:spcPts val="0"/>
+              </a:spcBef>
+              <a:spcAft>
+                <a:spcPts val="0"/>
               </a:spcAft>
               <a:buNone/>
             </a:pPr>
             <a:r>
-              <a:rPr lang="sk" sz="4600">
+              <a:rPr lang="sk" sz="2300">
                 <a:solidFill>
-                  <a:srgbClr val="D1D7E0"/>
+                  <a:schemeClr val="lt2"/>
                 </a:solidFill>
-                <a:highlight>
-                  <a:srgbClr val="212830"/>
-                </a:highlight>
               </a:rPr>
               <a:t>Team 4 - Popocatepetl</a:t>
             </a:r>
-            <a:endParaRPr/>
+            <a:endParaRPr sz="2300">
+              <a:solidFill>
+                <a:schemeClr val="lt2"/>
+              </a:solidFill>
+            </a:endParaRPr>
           </a:p>
         </p:txBody>
       </p:sp>
@@ -6085,8 +6085,8 @@
         </p:blipFill>
         <p:spPr>
           <a:xfrm>
-            <a:off x="1712750" y="1017725"/>
-            <a:ext cx="5780700" cy="3820974"/>
+            <a:off x="1522763" y="1017725"/>
+            <a:ext cx="6098474" cy="3979225"/>
           </a:xfrm>
           <a:prstGeom prst="rect">
             <a:avLst/>

</xml_diff>